<commit_message>
Use the original photos and align them on one row in the slides
Co-Authored-By: Claude Sonnet 5.5 <noreply@anthropic.com>
Claude-Session: https://claude.ai/code/session_01XeK1akFRrPbaN5jTKCPpsy
</commit_message>
<xml_diff>
--- a/steptember-showdown.pptx
+++ b/steptember-showdown.pptx
@@ -1809,7 +1809,7 @@
         <p:spPr>
           <a:xfrm>
             <a:off x="790956" y="4114800"/>
-            <a:ext cx="2926080" cy="1927555"/>
+            <a:ext cx="2926080" cy="1950415"/>
           </a:xfrm>
           <a:prstGeom prst="rect">
             <a:avLst/>
@@ -1833,7 +1833,7 @@
         <p:spPr>
           <a:xfrm>
             <a:off x="4631436" y="4114800"/>
-            <a:ext cx="2926080" cy="1938528"/>
+            <a:ext cx="2926080" cy="1950415"/>
           </a:xfrm>
           <a:prstGeom prst="rect">
             <a:avLst/>

</xml_diff>